<commit_message>
Actualiza la presentación con la captura del dashboard (FIG_5)
Incorpora la captura de pantalla del dashboard Dash + Plotly corriendo
en :8050 (lámina 12), la última figura que quedaba pendiente tras
completar FIG_1..FIG_4 en el commit anterior.

Co-Authored-By: Claude Sonnet 5 <noreply@anthropic.com>
</commit_message>
<xml_diff>
--- a/docs/presentacion_bikeshare.pptx
+++ b/docs/presentacion_bikeshare.pptx
@@ -126,6 +126,66 @@
     </p:ext>
   </p:extLst>
 </p:presentation>
+</file>
+
+<file path=ppt/changesInfos/changesInfo1.xml><?xml version="1.0" encoding="utf-8"?>
+<pc:chgInfo xmlns:a="http://schemas.openxmlformats.org/drawingml/2006/main" xmlns:r="http://schemas.openxmlformats.org/officeDocument/2006/relationships" xmlns:ac="http://schemas.microsoft.com/office/drawing/2013/main/command" xmlns:pc="http://schemas.microsoft.com/office/powerpoint/2013/main/command">
+  <pc:docChgLst>
+    <pc:chgData name="Hernan Lippke Vega" userId="62d0a3ca9726c884" providerId="LiveId" clId="{B94E0274-D47E-45CA-8207-D196DBFB5F3C}"/>
+    <pc:docChg chg="undo custSel modSld">
+      <pc:chgData name="Hernan Lippke Vega" userId="62d0a3ca9726c884" providerId="LiveId" clId="{B94E0274-D47E-45CA-8207-D196DBFB5F3C}" dt="2026-07-15T02:03:57.026" v="24" actId="1076"/>
+      <pc:docMkLst>
+        <pc:docMk/>
+      </pc:docMkLst>
+      <pc:sldChg chg="addSp modSp mod">
+        <pc:chgData name="Hernan Lippke Vega" userId="62d0a3ca9726c884" providerId="LiveId" clId="{B94E0274-D47E-45CA-8207-D196DBFB5F3C}" dt="2026-07-15T02:03:57.026" v="24" actId="1076"/>
+        <pc:sldMkLst>
+          <pc:docMk/>
+          <pc:sldMk cId="0" sldId="256"/>
+        </pc:sldMkLst>
+        <pc:spChg chg="mod">
+          <ac:chgData name="Hernan Lippke Vega" userId="62d0a3ca9726c884" providerId="LiveId" clId="{B94E0274-D47E-45CA-8207-D196DBFB5F3C}" dt="2026-07-15T02:03:32.461" v="20" actId="6549"/>
+          <ac:spMkLst>
+            <pc:docMk/>
+            <pc:sldMk cId="0" sldId="256"/>
+            <ac:spMk id="4" creationId="{00000000-0000-0000-0000-000000000000}"/>
+          </ac:spMkLst>
+        </pc:spChg>
+        <pc:picChg chg="add mod">
+          <ac:chgData name="Hernan Lippke Vega" userId="62d0a3ca9726c884" providerId="LiveId" clId="{B94E0274-D47E-45CA-8207-D196DBFB5F3C}" dt="2026-07-15T02:03:57.026" v="24" actId="1076"/>
+          <ac:picMkLst>
+            <pc:docMk/>
+            <pc:sldMk cId="0" sldId="256"/>
+            <ac:picMk id="18" creationId="{71476B6C-C35E-062C-8663-55C4A2E1B42B}"/>
+          </ac:picMkLst>
+        </pc:picChg>
+      </pc:sldChg>
+      <pc:sldChg chg="addSp delSp modSp mod">
+        <pc:chgData name="Hernan Lippke Vega" userId="62d0a3ca9726c884" providerId="LiveId" clId="{B94E0274-D47E-45CA-8207-D196DBFB5F3C}" dt="2026-07-15T02:02:22.547" v="17" actId="14100"/>
+        <pc:sldMkLst>
+          <pc:docMk/>
+          <pc:sldMk cId="0" sldId="267"/>
+        </pc:sldMkLst>
+        <pc:spChg chg="add del">
+          <ac:chgData name="Hernan Lippke Vega" userId="62d0a3ca9726c884" providerId="LiveId" clId="{B94E0274-D47E-45CA-8207-D196DBFB5F3C}" dt="2026-07-15T02:01:26.985" v="1" actId="478"/>
+          <ac:spMkLst>
+            <pc:docMk/>
+            <pc:sldMk cId="0" sldId="267"/>
+            <ac:spMk id="4" creationId="{00000000-0000-0000-0000-000000000000}"/>
+          </ac:spMkLst>
+        </pc:spChg>
+        <pc:picChg chg="add mod modCrop">
+          <ac:chgData name="Hernan Lippke Vega" userId="62d0a3ca9726c884" providerId="LiveId" clId="{B94E0274-D47E-45CA-8207-D196DBFB5F3C}" dt="2026-07-15T02:02:22.547" v="17" actId="14100"/>
+          <ac:picMkLst>
+            <pc:docMk/>
+            <pc:sldMk cId="0" sldId="267"/>
+            <ac:picMk id="31" creationId="{32ADC305-B008-B756-390E-1266088F3757}"/>
+          </ac:picMkLst>
+        </pc:picChg>
+      </pc:sldChg>
+    </pc:docChg>
+  </pc:docChgLst>
+</pc:chgInfo>
 </file>
 
 <file path=ppt/charts/chart1.xml><?xml version="1.0" encoding="utf-8"?>
@@ -2895,14 +2955,6 @@
             <a:pPr marL="0" indent="0">
               <a:buNone/>
             </a:pPr>
-            <a:r>
-              <a:rPr lang="en-US" sz="6000" dirty="0">
-                <a:solidFill>
-                  <a:srgbClr val="000000"/>
-                </a:solidFill>
-              </a:rPr>
-              <a:t>🚲</a:t>
-            </a:r>
             <a:endParaRPr lang="en-US" sz="6000" dirty="0"/>
           </a:p>
         </p:txBody>
@@ -3378,6 +3430,36 @@
           </a:p>
         </p:txBody>
       </p:sp>
+      <p:pic>
+        <p:nvPicPr>
+          <p:cNvPr id="18" name="Image 0" descr="charts_t/logo_color.png">
+            <a:extLst>
+              <a:ext uri="{FF2B5EF4-FFF2-40B4-BE49-F238E27FC236}">
+                <a16:creationId xmlns:a16="http://schemas.microsoft.com/office/drawing/2014/main" id="{71476B6C-C35E-062C-8663-55C4A2E1B42B}"/>
+              </a:ext>
+            </a:extLst>
+          </p:cNvPr>
+          <p:cNvPicPr>
+            <a:picLocks noChangeAspect="1"/>
+          </p:cNvPicPr>
+          <p:nvPr/>
+        </p:nvPicPr>
+        <p:blipFill>
+          <a:blip r:embed="rId3"/>
+          <a:stretch>
+            <a:fillRect/>
+          </a:stretch>
+        </p:blipFill>
+        <p:spPr>
+          <a:xfrm>
+            <a:off x="3177821" y="137160"/>
+            <a:ext cx="6172199" cy="1508760"/>
+          </a:xfrm>
+          <a:prstGeom prst="rect">
+            <a:avLst/>
+          </a:prstGeom>
+        </p:spPr>
+      </p:pic>
     </p:spTree>
   </p:cSld>
   <p:clrMapOvr>
@@ -7495,6 +7577,37 @@
           </a:p>
         </p:txBody>
       </p:sp>
+      <p:pic>
+        <p:nvPicPr>
+          <p:cNvPr id="31" name="Imagen 30">
+            <a:extLst>
+              <a:ext uri="{FF2B5EF4-FFF2-40B4-BE49-F238E27FC236}">
+                <a16:creationId xmlns:a16="http://schemas.microsoft.com/office/drawing/2014/main" id="{32ADC305-B008-B756-390E-1266088F3757}"/>
+              </a:ext>
+            </a:extLst>
+          </p:cNvPr>
+          <p:cNvPicPr>
+            <a:picLocks noChangeAspect="1"/>
+          </p:cNvPicPr>
+          <p:nvPr/>
+        </p:nvPicPr>
+        <p:blipFill>
+          <a:blip r:embed="rId3"/>
+          <a:srcRect t="10885"/>
+          <a:stretch>
+            <a:fillRect/>
+          </a:stretch>
+        </p:blipFill>
+        <p:spPr>
+          <a:xfrm>
+            <a:off x="563879" y="1397352"/>
+            <a:ext cx="6631887" cy="3734112"/>
+          </a:xfrm>
+          <a:prstGeom prst="rect">
+            <a:avLst/>
+          </a:prstGeom>
+        </p:spPr>
+      </p:pic>
     </p:spTree>
   </p:cSld>
   <p:clrMapOvr>

</xml_diff>